<commit_message>
docs(qa): update delivery 1 documents for group 7
</commit_message>
<xml_diff>
--- a/qa/entrega-1/Presentacion_Entrega1_QA_PanelOrganizador.pptx
+++ b/qa/entrega-1/Presentacion_Entrega1_QA_PanelOrganizador.pptx
@@ -1730,7 +1730,7 @@
                 <a:ea typeface="Helvetica" pitchFamily="34" charset="-122"/>
                 <a:cs typeface="Helvetica" pitchFamily="34" charset="-120"/>
               </a:rPr>
-              <a:t>Microservicio 7 · Panel Organizador (TicketU)</a:t>
+              <a:t>Grupo 7 · Microservicio 7 · Panel Organizador (TicketU)</a:t>
             </a:r>
             <a:endParaRPr lang="en-US" sz="2200" dirty="0"/>
           </a:p>
@@ -1774,7 +1774,51 @@
                 <a:ea typeface="Helvetica" pitchFamily="34" charset="-122"/>
                 <a:cs typeface="Helvetica" pitchFamily="34" charset="-120"/>
               </a:rPr>
-              <a:t>Grupo 1 · Lucas Rojas · Alonso Vera · Christopher Okinggton · Joaquín Martínez · Viernes 23/10/2026</a:t>
+              <a:t>Lucas Rojas · Alonso Vera · Christopher Okinggton · Joaquín Martínez</a:t>
+            </a:r>
+            <a:endParaRPr lang="en-US" sz="1500" dirty="0"/>
+          </a:p>
+        </p:txBody>
+      </p:sp>
+      <p:sp>
+        <p:nvSpPr>
+          <p:cNvPr id="5" name="Text 3"/>
+          <p:cNvSpPr/>
+          <p:nvPr/>
+        </p:nvSpPr>
+        <p:spPr>
+          <a:xfrm>
+            <a:off x="812800" y="3889640"/>
+            <a:ext cx="10883392" cy="292100"/>
+          </a:xfrm>
+          <a:prstGeom prst="rect">
+            <a:avLst/>
+          </a:prstGeom>
+          <a:noFill/>
+          <a:ln/>
+        </p:spPr>
+        <p:txBody>
+          <a:bodyPr wrap="square" lIns="0" tIns="0" rIns="0" bIns="0" rtlCol="0" anchor="t">
+            <a:normAutofit/>
+          </a:bodyPr>
+          <a:lstStyle/>
+          <a:p>
+            <a:pPr algn="l" indent="0" marL="0">
+              <a:lnSpc>
+                <a:spcPts val="2100"/>
+              </a:lnSpc>
+              <a:buNone/>
+            </a:pPr>
+            <a:r>
+              <a:rPr lang="en-US" sz="1500" dirty="0">
+                <a:solidFill>
+                  <a:srgbClr val="F6F4EF"/>
+                </a:solidFill>
+                <a:latin typeface="Helvetica" pitchFamily="34" charset="0"/>
+                <a:ea typeface="Helvetica" pitchFamily="34" charset="-122"/>
+                <a:cs typeface="Helvetica" pitchFamily="34" charset="-120"/>
+              </a:rPr>
+              <a:t>Viernes 23/10/2026</a:t>
             </a:r>
             <a:endParaRPr lang="en-US" sz="1500" dirty="0"/>
           </a:p>

</xml_diff>

<commit_message>
docs(qa): simplify findings slide and team slide in presentation
</commit_message>
<xml_diff>
--- a/qa/entrega-1/Presentacion_Entrega1_QA_PanelOrganizador.pptx
+++ b/qa/entrega-1/Presentacion_Entrega1_QA_PanelOrganizador.pptx
@@ -1730,7 +1730,7 @@
                 <a:ea typeface="Helvetica" pitchFamily="34" charset="-122"/>
                 <a:cs typeface="Helvetica" pitchFamily="34" charset="-120"/>
               </a:rPr>
-              <a:t>Grupo 7 · Microservicio 7 · Panel Organizador (TicketU)</a:t>
+              <a:t>Grupo 7 · Microservicio Panel Organizador (TicketU)</a:t>
             </a:r>
             <a:endParaRPr lang="en-US" sz="2200" dirty="0"/>
           </a:p>
@@ -2461,68 +2461,6 @@
               <a:t>Interfaz y exploratorios, ambiente y herramientas: AUT-06 y UI; Docker, TestLink y Mantis (R12, R15, R18).</a:t>
             </a:r>
             <a:endParaRPr lang="en-US" sz="1400" dirty="0"/>
-          </a:p>
-        </p:txBody>
-      </p:sp>
-      <p:sp>
-        <p:nvSpPr>
-          <p:cNvPr id="12" name="Text 10"/>
-          <p:cNvSpPr/>
-          <p:nvPr/>
-        </p:nvSpPr>
-        <p:spPr>
-          <a:xfrm>
-            <a:off x="812800" y="4100000"/>
-            <a:ext cx="10883392" cy="700000"/>
-          </a:xfrm>
-          <a:prstGeom prst="rect">
-            <a:avLst/>
-          </a:prstGeom>
-          <a:noFill/>
-          <a:ln/>
-        </p:spPr>
-        <p:txBody>
-          <a:bodyPr wrap="square" lIns="0" tIns="0" rIns="0" bIns="0" rtlCol="0" anchor="t"/>
-          <a:lstStyle/>
-          <a:p>
-            <a:pPr algn="l" indent="0" marL="0">
-              <a:lnSpc>
-                <a:spcPts val="2100"/>
-              </a:lnSpc>
-              <a:buNone/>
-            </a:pPr>
-            <a:r>
-              <a:rPr lang="en-US" sz="1500" dirty="0" b="0">
-                <a:solidFill>
-                  <a:srgbClr val="1B2430"/>
-                </a:solidFill>
-                <a:latin typeface="Helvetica" pitchFamily="34" charset="0"/>
-                <a:ea typeface="Helvetica" pitchFamily="34" charset="-122"/>
-                <a:cs typeface="Helvetica" pitchFamily="34" charset="-120"/>
-              </a:rPr>
-              <a:t>Dedicación: 8 h por semana cada uno (25 %). Esfuerzo estimado de la Entrega 1: 52 h.</a:t>
-            </a:r>
-            <a:endParaRPr lang="en-US" sz="1500" dirty="0"/>
-          </a:p>
-          <a:p>
-            <a:pPr algn="l" indent="0" marL="0">
-              <a:lnSpc>
-                <a:spcPts val="2100"/>
-              </a:lnSpc>
-              <a:buNone/>
-            </a:pPr>
-            <a:r>
-              <a:rPr lang="en-US" sz="1500" dirty="0" b="0">
-                <a:solidFill>
-                  <a:srgbClr val="1B2430"/>
-                </a:solidFill>
-                <a:latin typeface="Helvetica" pitchFamily="34" charset="0"/>
-                <a:ea typeface="Helvetica" pitchFamily="34" charset="-122"/>
-                <a:cs typeface="Helvetica" pitchFamily="34" charset="-120"/>
-              </a:rPr>
-              <a:t>Presentan: Lucas (1–4) · Alonso (5–6) · Christopher (7–8) · Joaquín (9–10).</a:t>
-            </a:r>
-            <a:endParaRPr lang="en-US" sz="1500" dirty="0"/>
           </a:p>
         </p:txBody>
       </p:sp>
@@ -11993,224 +11931,9 @@
                 <a:ea typeface="Georgia" pitchFamily="18" charset="-122"/>
                 <a:cs typeface="Georgia" pitchFamily="18" charset="-120"/>
               </a:rPr>
-              <a:t>Hallazgos de revisión estática y próximos pasos</a:t>
+              <a:t>Hallazgos de la revisión estática y próximos pasos</a:t>
             </a:r>
             <a:endParaRPr lang="en-US" sz="3000" dirty="0"/>
-          </a:p>
-        </p:txBody>
-      </p:sp>
-      <p:sp>
-        <p:nvSpPr>
-          <p:cNvPr id="3" name="Shape 1"/>
-          <p:cNvSpPr/>
-          <p:nvPr/>
-        </p:nvSpPr>
-        <p:spPr>
-          <a:xfrm>
-            <a:off x="815975" y="1463675"/>
-            <a:ext cx="5175250" cy="4400000"/>
-          </a:xfrm>
-          <a:prstGeom prst="roundRect">
-            <a:avLst>
-              <a:gd name="adj" fmla="val 3610"/>
-            </a:avLst>
-          </a:prstGeom>
-          <a:solidFill>
-            <a:srgbClr val="FFFFFF"/>
-          </a:solidFill>
-          <a:ln w="6350">
-            <a:solidFill>
-              <a:srgbClr val="DCD8CF"/>
-            </a:solidFill>
-            <a:prstDash val="solid"/>
-          </a:ln>
-        </p:spPr>
-      </p:sp>
-      <p:sp>
-        <p:nvSpPr>
-          <p:cNvPr id="4" name="Text 2"/>
-          <p:cNvSpPr/>
-          <p:nvPr/>
-        </p:nvSpPr>
-        <p:spPr>
-          <a:xfrm>
-            <a:off x="1046480" y="1694182"/>
-            <a:ext cx="4855667" cy="269240"/>
-          </a:xfrm>
-          <a:prstGeom prst="rect">
-            <a:avLst/>
-          </a:prstGeom>
-          <a:noFill/>
-          <a:ln/>
-        </p:spPr>
-        <p:txBody>
-          <a:bodyPr wrap="square" lIns="0" tIns="0" rIns="0" bIns="0" rtlCol="0" anchor="t">
-            <a:normAutofit/>
-          </a:bodyPr>
-          <a:lstStyle/>
-          <a:p>
-            <a:pPr algn="l" indent="0" marL="0">
-              <a:lnSpc>
-                <a:spcPts val="1920"/>
-              </a:lnSpc>
-              <a:buNone/>
-            </a:pPr>
-            <a:r>
-              <a:rPr lang="en-US" sz="1600" b="1" dirty="0">
-                <a:solidFill>
-                  <a:srgbClr val="1F6F68"/>
-                </a:solidFill>
-                <a:latin typeface="Helvetica" pitchFamily="34" charset="0"/>
-                <a:ea typeface="Helvetica" pitchFamily="34" charset="-122"/>
-                <a:cs typeface="Helvetica" pitchFamily="34" charset="-120"/>
-              </a:rPr>
-              <a:t>Hallazgos</a:t>
-            </a:r>
-            <a:endParaRPr lang="en-US" sz="1600" dirty="0"/>
-          </a:p>
-        </p:txBody>
-      </p:sp>
-      <p:sp>
-        <p:nvSpPr>
-          <p:cNvPr id="5" name="Text 3"/>
-          <p:cNvSpPr/>
-          <p:nvPr/>
-        </p:nvSpPr>
-        <p:spPr>
-          <a:xfrm>
-            <a:off x="1046480" y="2039621"/>
-            <a:ext cx="4855667" cy="3800000"/>
-          </a:xfrm>
-          <a:prstGeom prst="rect">
-            <a:avLst/>
-          </a:prstGeom>
-          <a:noFill/>
-          <a:ln/>
-        </p:spPr>
-        <p:txBody>
-          <a:bodyPr wrap="square" lIns="0" tIns="0" rIns="0" bIns="0" rtlCol="0" anchor="t">
-            <a:normAutofit/>
-          </a:bodyPr>
-          <a:lstStyle/>
-          <a:p>
-            <a:pPr algn="l" indent="0" marL="0">
-              <a:lnSpc>
-                <a:spcPts val="1890"/>
-              </a:lnSpc>
-              <a:buNone/>
-            </a:pPr>
-            <a:r>
-              <a:rPr lang="en-US" sz="1400" b="0" dirty="0">
-                <a:solidFill>
-                  <a:srgbClr val="1B2430"/>
-                </a:solidFill>
-                <a:latin typeface="Helvetica" pitchFamily="34" charset="0"/>
-                <a:ea typeface="Helvetica" pitchFamily="34" charset="-122"/>
-                <a:cs typeface="Helvetica" pitchFamily="34" charset="-120"/>
-              </a:rPr>
-              <a:t>• Publicar no vuelve a validar la fecha: un Borrador cuya fecha ya pasó se puede publicar (HU-04 no lo exige; caso FEC-06).</a:t>
-            </a:r>
-            <a:endParaRPr lang="en-US" sz="1400" dirty="0"/>
-          </a:p>
-          <a:p>
-            <a:pPr algn="l" indent="0" marL="0">
-              <a:lnSpc>
-                <a:spcPts val="1890"/>
-              </a:lnSpc>
-              <a:buNone/>
-            </a:pPr>
-            <a:r>
-              <a:rPr lang="en-US" sz="1400" b="0" dirty="0">
-                <a:solidFill>
-                  <a:srgbClr val="1B2430"/>
-                </a:solidFill>
-                <a:latin typeface="Helvetica" pitchFamily="34" charset="0"/>
-                <a:ea typeface="Helvetica" pitchFamily="34" charset="-122"/>
-                <a:cs typeface="Helvetica" pitchFamily="34" charset="-120"/>
-              </a:rPr>
-              <a:t>• El historial de cambios de un Borrador se ve sin sesión (EXP-03).</a:t>
-            </a:r>
-            <a:endParaRPr lang="en-US" sz="1400" dirty="0"/>
-          </a:p>
-          <a:p>
-            <a:pPr algn="l" indent="0" marL="0">
-              <a:lnSpc>
-                <a:spcPts val="1890"/>
-              </a:lnSpc>
-              <a:buNone/>
-            </a:pPr>
-            <a:r>
-              <a:rPr lang="en-US" sz="1400" b="0" dirty="0">
-                <a:solidFill>
-                  <a:srgbClr val="1B2430"/>
-                </a:solidFill>
-                <a:latin typeface="Helvetica" pitchFamily="34" charset="0"/>
-                <a:ea typeface="Helvetica" pitchFamily="34" charset="-122"/>
-                <a:cs typeface="Helvetica" pitchFamily="34" charset="-120"/>
-              </a:rPr>
-              <a:t>• Check-in v1.2 pide errores { codigo_http, error, mensaje }; el resto de la API usa otro formato (CON-05).</a:t>
-            </a:r>
-            <a:endParaRPr lang="en-US" sz="1400" dirty="0"/>
-          </a:p>
-          <a:p>
-            <a:pPr algn="l" indent="0" marL="0">
-              <a:lnSpc>
-                <a:spcPts val="1890"/>
-              </a:lnSpc>
-              <a:buNone/>
-            </a:pPr>
-            <a:r>
-              <a:rPr lang="en-US" sz="1400" b="0" dirty="0">
-                <a:solidFill>
-                  <a:srgbClr val="1B2430"/>
-                </a:solidFill>
-                <a:latin typeface="Helvetica" pitchFamily="34" charset="0"/>
-                <a:ea typeface="Helvetica" pitchFamily="34" charset="-122"/>
-                <a:cs typeface="Helvetica" pitchFamily="34" charset="-120"/>
-              </a:rPr>
-              <a:t>• Un organizador puede leer eventos ajenos por el GET compartido de Entradas y Check-in (PRO-04, consulta a TITEC).</a:t>
-            </a:r>
-            <a:endParaRPr lang="en-US" sz="1400" dirty="0"/>
-          </a:p>
-          <a:p>
-            <a:pPr algn="l" indent="0" marL="0">
-              <a:lnSpc>
-                <a:spcPts val="1890"/>
-              </a:lnSpc>
-              <a:buNone/>
-            </a:pPr>
-            <a:r>
-              <a:rPr lang="en-US" sz="1400" b="0" dirty="0">
-                <a:solidFill>
-                  <a:srgbClr val="1B2430"/>
-                </a:solidFill>
-                <a:latin typeface="Helvetica" pitchFamily="34" charset="0"/>
-                <a:ea typeface="Helvetica" pitchFamily="34" charset="-122"/>
-                <a:cs typeface="Helvetica" pitchFamily="34" charset="-120"/>
-              </a:rPr>
-              <a:t>• Los 5 contratos tienen el tópico «pendiente de acuerdo»: HU-07 se prueba sobre la tabla de salida (NOT-01).</a:t>
-            </a:r>
-            <a:endParaRPr lang="en-US" sz="1400" dirty="0"/>
-          </a:p>
-          <a:p>
-            <a:pPr algn="l" indent="0" marL="0">
-              <a:lnSpc>
-                <a:spcPts val="1890"/>
-              </a:lnSpc>
-              <a:buNone/>
-            </a:pPr>
-            <a:r>
-              <a:rPr lang="en-US" sz="1400" b="0" dirty="0">
-                <a:solidFill>
-                  <a:srgbClr val="1B2430"/>
-                </a:solidFill>
-                <a:latin typeface="Helvetica" pitchFamily="34" charset="0"/>
-                <a:ea typeface="Helvetica" pitchFamily="34" charset="-122"/>
-                <a:cs typeface="Helvetica" pitchFamily="34" charset="-120"/>
-              </a:rPr>
-              <a:t>• OpenAPI del Avance 1: tags partidos en tres y rutas que mezclan /panel y /organizador.</a:t>
-            </a:r>
-            <a:endParaRPr lang="en-US" sz="1400" dirty="0"/>
           </a:p>
         </p:txBody>
       </p:sp>
@@ -12222,8 +11945,8 @@
         </p:nvSpPr>
         <p:spPr>
           <a:xfrm>
-            <a:off x="6200775" y="1463675"/>
-            <a:ext cx="5175250" cy="4400000"/>
+            <a:off x="8162800" y="1463675"/>
+            <a:ext cx="3533392" cy="3360000"/>
           </a:xfrm>
           <a:prstGeom prst="roundRect">
             <a:avLst>
@@ -12249,8 +11972,8 @@
         </p:nvSpPr>
         <p:spPr>
           <a:xfrm>
-            <a:off x="6431280" y="1694182"/>
-            <a:ext cx="4855667" cy="269240"/>
+            <a:off x="8393305" y="1694182"/>
+            <a:ext cx="3072382" cy="269240"/>
           </a:xfrm>
           <a:prstGeom prst="rect">
             <a:avLst/>
@@ -12293,8 +12016,8 @@
         </p:nvSpPr>
         <p:spPr>
           <a:xfrm>
-            <a:off x="6431280" y="2039621"/>
-            <a:ext cx="4855667" cy="3800000"/>
+            <a:off x="8393305" y="2039621"/>
+            <a:ext cx="3072382" cy="3200000"/>
           </a:xfrm>
           <a:prstGeom prst="rect">
             <a:avLst/>
@@ -12303,15 +12026,16 @@
           <a:ln/>
         </p:spPr>
         <p:txBody>
-          <a:bodyPr wrap="square" lIns="0" tIns="0" rIns="0" bIns="0" rtlCol="0" anchor="t">
-            <a:normAutofit/>
-          </a:bodyPr>
+          <a:bodyPr wrap="square" lIns="0" tIns="0" rIns="0" bIns="0" rtlCol="0" anchor="t"/>
           <a:lstStyle/>
           <a:p>
             <a:pPr algn="l" indent="0" marL="0">
               <a:lnSpc>
                 <a:spcPts val="1890"/>
               </a:lnSpc>
+              <a:spcAft>
+                <a:spcPts val="1000"/>
+              </a:spcAft>
               <a:buNone/>
             </a:pPr>
             <a:r>
@@ -12323,7 +12047,7 @@
                 <a:ea typeface="Helvetica" pitchFamily="34" charset="-122"/>
                 <a:cs typeface="Helvetica" pitchFamily="34" charset="-120"/>
               </a:rPr>
-              <a:t>• Plan de pruebas en TestLink con los 36 de la Entrega 1 (keyword «PO · Entrega 1 · priorizado») y el build del commit 1d8a68e.</a:t>
+              <a:t>1. Plan de pruebas y build en TestLink con los 36 casos de la Entrega 1.</a:t>
             </a:r>
             <a:endParaRPr lang="en-US" sz="1400" dirty="0"/>
           </a:p>
@@ -12332,6 +12056,9 @@
               <a:lnSpc>
                 <a:spcPts val="1890"/>
               </a:lnSpc>
+              <a:spcAft>
+                <a:spcPts val="1000"/>
+              </a:spcAft>
               <a:buNone/>
             </a:pPr>
             <a:r>
@@ -12343,7 +12070,7 @@
                 <a:ea typeface="Helvetica" pitchFamily="34" charset="-122"/>
                 <a:cs typeface="Helvetica" pitchFamily="34" charset="-120"/>
               </a:rPr>
-              <a:t>• Ejecutar primero R1 → R4 y reportar los Failed en Mantis.</a:t>
+              <a:t>2. Ejecutar primero R1 a R4 y reportar los fallos en Mantis.</a:t>
             </a:r>
             <a:endParaRPr lang="en-US" sz="1400" dirty="0"/>
           </a:p>
@@ -12352,6 +12079,9 @@
               <a:lnSpc>
                 <a:spcPts val="1890"/>
               </a:lnSpc>
+              <a:spcAft>
+                <a:spcPts val="1000"/>
+              </a:spcAft>
               <a:buNone/>
             </a:pPr>
             <a:r>
@@ -12363,7 +12093,7 @@
                 <a:ea typeface="Helvetica" pitchFamily="34" charset="-122"/>
                 <a:cs typeface="Helvetica" pitchFamily="34" charset="-120"/>
               </a:rPr>
-              <a:t>• Acordar con TITEC los tópicos del broker (R13) para probar HU-07.</a:t>
+              <a:t>3. Acordar con TITEC los tópicos del broker.</a:t>
             </a:r>
             <a:endParaRPr lang="en-US" sz="1400" dirty="0"/>
           </a:p>
@@ -12372,6 +12102,9 @@
               <a:lnSpc>
                 <a:spcPts val="1890"/>
               </a:lnSpc>
+              <a:spcAft>
+                <a:spcPts val="1000"/>
+              </a:spcAft>
               <a:buNone/>
             </a:pPr>
             <a:r>
@@ -12383,27 +12116,7 @@
                 <a:ea typeface="Helvetica" pitchFamily="34" charset="-122"/>
                 <a:cs typeface="Helvetica" pitchFamily="34" charset="-120"/>
               </a:rPr>
-              <a:t>• Ejecutar HU-02 y NOT-01 sobre el Avance 2 (22/10) y los E2E en la Entrega 3.</a:t>
-            </a:r>
-            <a:endParaRPr lang="en-US" sz="1400" dirty="0"/>
-          </a:p>
-          <a:p>
-            <a:pPr algn="l" indent="0" marL="0">
-              <a:lnSpc>
-                <a:spcPts val="1890"/>
-              </a:lnSpc>
-              <a:buNone/>
-            </a:pPr>
-            <a:r>
-              <a:rPr lang="en-US" sz="1400" dirty="0" b="0">
-                <a:solidFill>
-                  <a:srgbClr val="1B2430"/>
-                </a:solidFill>
-                <a:latin typeface="Helvetica" pitchFamily="34" charset="0"/>
-                <a:ea typeface="Helvetica" pitchFamily="34" charset="-122"/>
-                <a:cs typeface="Helvetica" pitchFamily="34" charset="-120"/>
-              </a:rPr>
-              <a:t>• Ajustar el plan cuando se definan las Entregas 2 y 3.</a:t>
+              <a:t>4. Avance 2: HU-02 y NOT-01. Entrega 3: los E2E.</a:t>
             </a:r>
             <a:endParaRPr lang="en-US" sz="1400" dirty="0"/>
           </a:p>
@@ -12450,6 +12163,1782 @@
               <a:t>QA · Panel Organizador · Entrega 1 · Pruebas de Sistema</a:t>
             </a:r>
             <a:endParaRPr lang="en-US" sz="1200" dirty="0"/>
+          </a:p>
+        </p:txBody>
+      </p:sp>
+      <p:graphicFrame>
+        <p:nvGraphicFramePr>
+          <p:cNvPr id="3" name="Table 0"/>
+          <p:cNvGraphicFramePr>
+            <a:graphicFrameLocks noGrp="1"/>
+          </p:cNvGraphicFramePr>
+          <p:nvPr>
+            <p:extLst>
+              <p:ext uri="{D42A27DB-BD31-4B8C-83A1-F6EECF244321}">
+                <p14:modId xmlns:p14="http://schemas.microsoft.com/office/powerpoint/2010/main" val="1579011935"/>
+              </p:ext>
+            </p:extLst>
+          </p:nvPr>
+        </p:nvGraphicFramePr>
+        <p:xfrm>
+          <a:off x="812800" y="1463675"/>
+          <a:ext cx="7100000" cy="3360000"/>
+        </p:xfrm>
+        <a:graphic>
+          <a:graphicData uri="http://schemas.openxmlformats.org/drawingml/2006/table">
+            <a:tbl>
+              <a:tblPr/>
+              <a:tblGrid>
+                <a:gridCol w="5000000"/>
+                <a:gridCol w="1000000"/>
+                <a:gridCol w="1100000"/>
+              </a:tblGrid>
+              <a:tr h="480000">
+                <a:tc>
+                  <a:txBody>
+                    <a:bodyPr/>
+                    <a:lstStyle/>
+                    <a:p>
+                      <a:pPr indent="0" marL="0">
+                        <a:lnSpc>
+                          <a:spcPts val="1960"/>
+                        </a:lnSpc>
+                        <a:buNone/>
+                      </a:pPr>
+                      <a:r>
+                        <a:rPr lang="en-US" sz="1300" b="1" dirty="0">
+                          <a:solidFill>
+                            <a:srgbClr val="F6F4EF"/>
+                          </a:solidFill>
+                          <a:latin typeface="Helvetica" pitchFamily="34" charset="0"/>
+                          <a:ea typeface="Helvetica" pitchFamily="34" charset="-122"/>
+                          <a:cs typeface="Helvetica" pitchFamily="34" charset="-120"/>
+                        </a:rPr>
+                        <a:t>Hallazgo</a:t>
+                      </a:r>
+                      <a:endParaRPr lang="en-US" sz="1400" dirty="0">
+                        <a:latin typeface="Helvetica" charset="0"/>
+                        <a:ea typeface="Helvetica" charset="0"/>
+                        <a:cs typeface="Helvetica" charset="0"/>
+                      </a:endParaRPr>
+                    </a:p>
+                  </a:txBody>
+                  <a:tcPr marL="114300" marR="114300" marT="76200" marB="76200" anchor="t">
+                    <a:lnL w="12700" cap="flat" cmpd="sng" algn="ctr">
+                      <a:solidFill>
+                        <a:srgbClr val="C4C3BF"/>
+                      </a:solidFill>
+                      <a:prstDash val="solid"/>
+                      <a:round/>
+                      <a:headEnd type="none" w="med" len="med"/>
+                      <a:tailEnd type="none" w="med" len="med"/>
+                    </a:lnL>
+                    <a:lnR w="12700" cap="flat" cmpd="sng" algn="ctr">
+                      <a:solidFill>
+                        <a:srgbClr val="19202A"/>
+                      </a:solidFill>
+                      <a:prstDash val="solid"/>
+                      <a:round/>
+                      <a:headEnd type="none" w="med" len="med"/>
+                      <a:tailEnd type="none" w="med" len="med"/>
+                    </a:lnR>
+                    <a:lnT w="12700" cap="flat" cmpd="sng" algn="ctr">
+                      <a:solidFill>
+                        <a:srgbClr val="C4C3BF"/>
+                      </a:solidFill>
+                      <a:prstDash val="solid"/>
+                      <a:round/>
+                      <a:headEnd type="none" w="med" len="med"/>
+                      <a:tailEnd type="none" w="med" len="med"/>
+                    </a:lnT>
+                    <a:lnB w="12700" cap="flat" cmpd="sng" algn="ctr">
+                      <a:solidFill>
+                        <a:srgbClr val="19202A"/>
+                      </a:solidFill>
+                      <a:prstDash val="solid"/>
+                      <a:round/>
+                      <a:headEnd type="none" w="med" len="med"/>
+                      <a:tailEnd type="none" w="med" len="med"/>
+                    </a:lnB>
+                    <a:solidFill>
+                      <a:srgbClr val="1B2430"/>
+                    </a:solidFill>
+                  </a:tcPr>
+                </a:tc>
+                <a:tc>
+                  <a:txBody>
+                    <a:bodyPr/>
+                    <a:lstStyle/>
+                    <a:p>
+                      <a:pPr indent="0" marL="0">
+                        <a:lnSpc>
+                          <a:spcPts val="1960"/>
+                        </a:lnSpc>
+                        <a:buNone/>
+                      </a:pPr>
+                      <a:r>
+                        <a:rPr lang="en-US" sz="1300" b="1" dirty="0">
+                          <a:solidFill>
+                            <a:srgbClr val="F6F4EF"/>
+                          </a:solidFill>
+                          <a:latin typeface="Helvetica" pitchFamily="34" charset="0"/>
+                          <a:ea typeface="Helvetica" pitchFamily="34" charset="-122"/>
+                          <a:cs typeface="Helvetica" pitchFamily="34" charset="-120"/>
+                        </a:rPr>
+                        <a:t>Caso</a:t>
+                      </a:r>
+                      <a:endParaRPr lang="en-US" sz="1400" dirty="0">
+                        <a:latin typeface="Helvetica" charset="0"/>
+                        <a:ea typeface="Helvetica" charset="0"/>
+                        <a:cs typeface="Helvetica" charset="0"/>
+                      </a:endParaRPr>
+                    </a:p>
+                  </a:txBody>
+                  <a:tcPr marL="114300" marR="114300" marT="76200" marB="76200" anchor="t">
+                    <a:lnL w="12700" cap="flat" cmpd="sng" algn="ctr">
+                      <a:solidFill>
+                        <a:srgbClr val="19202A"/>
+                      </a:solidFill>
+                      <a:prstDash val="solid"/>
+                      <a:round/>
+                      <a:headEnd type="none" w="med" len="med"/>
+                      <a:tailEnd type="none" w="med" len="med"/>
+                    </a:lnL>
+                    <a:lnR w="12700" cap="flat" cmpd="sng" algn="ctr">
+                      <a:solidFill>
+                        <a:srgbClr val="19202A"/>
+                      </a:solidFill>
+                      <a:prstDash val="solid"/>
+                      <a:round/>
+                      <a:headEnd type="none" w="med" len="med"/>
+                      <a:tailEnd type="none" w="med" len="med"/>
+                    </a:lnR>
+                    <a:lnT w="12700" cap="flat" cmpd="sng" algn="ctr">
+                      <a:solidFill>
+                        <a:srgbClr val="C4C3BF"/>
+                      </a:solidFill>
+                      <a:prstDash val="solid"/>
+                      <a:round/>
+                      <a:headEnd type="none" w="med" len="med"/>
+                      <a:tailEnd type="none" w="med" len="med"/>
+                    </a:lnT>
+                    <a:lnB w="12700" cap="flat" cmpd="sng" algn="ctr">
+                      <a:solidFill>
+                        <a:srgbClr val="19202A"/>
+                      </a:solidFill>
+                      <a:prstDash val="solid"/>
+                      <a:round/>
+                      <a:headEnd type="none" w="med" len="med"/>
+                      <a:tailEnd type="none" w="med" len="med"/>
+                    </a:lnB>
+                    <a:solidFill>
+                      <a:srgbClr val="1B2430"/>
+                    </a:solidFill>
+                  </a:tcPr>
+                </a:tc>
+                <a:tc>
+                  <a:txBody>
+                    <a:bodyPr/>
+                    <a:lstStyle/>
+                    <a:p>
+                      <a:pPr indent="0" marL="0">
+                        <a:lnSpc>
+                          <a:spcPts val="1960"/>
+                        </a:lnSpc>
+                        <a:buNone/>
+                      </a:pPr>
+                      <a:r>
+                        <a:rPr lang="en-US" sz="1300" b="1" dirty="0">
+                          <a:solidFill>
+                            <a:srgbClr val="F6F4EF"/>
+                          </a:solidFill>
+                          <a:latin typeface="Helvetica" pitchFamily="34" charset="0"/>
+                          <a:ea typeface="Helvetica" pitchFamily="34" charset="-122"/>
+                          <a:cs typeface="Helvetica" pitchFamily="34" charset="-120"/>
+                        </a:rPr>
+                        <a:t>Prioridad</a:t>
+                      </a:r>
+                      <a:endParaRPr lang="en-US" sz="1400" dirty="0">
+                        <a:latin typeface="Helvetica" charset="0"/>
+                        <a:ea typeface="Helvetica" charset="0"/>
+                        <a:cs typeface="Helvetica" charset="0"/>
+                      </a:endParaRPr>
+                    </a:p>
+                  </a:txBody>
+                  <a:tcPr marL="114300" marR="114300" marT="76200" marB="76200" anchor="t">
+                    <a:lnL w="12700" cap="flat" cmpd="sng" algn="ctr">
+                      <a:solidFill>
+                        <a:srgbClr val="19202A"/>
+                      </a:solidFill>
+                      <a:prstDash val="solid"/>
+                      <a:round/>
+                      <a:headEnd type="none" w="med" len="med"/>
+                      <a:tailEnd type="none" w="med" len="med"/>
+                    </a:lnL>
+                    <a:lnR w="12700" cap="flat" cmpd="sng" algn="ctr">
+                      <a:solidFill>
+                        <a:srgbClr val="19202A"/>
+                      </a:solidFill>
+                      <a:prstDash val="solid"/>
+                      <a:round/>
+                      <a:headEnd type="none" w="med" len="med"/>
+                      <a:tailEnd type="none" w="med" len="med"/>
+                    </a:lnR>
+                    <a:lnT w="12700" cap="flat" cmpd="sng" algn="ctr">
+                      <a:solidFill>
+                        <a:srgbClr val="C4C3BF"/>
+                      </a:solidFill>
+                      <a:prstDash val="solid"/>
+                      <a:round/>
+                      <a:headEnd type="none" w="med" len="med"/>
+                      <a:tailEnd type="none" w="med" len="med"/>
+                    </a:lnT>
+                    <a:lnB w="12700" cap="flat" cmpd="sng" algn="ctr">
+                      <a:solidFill>
+                        <a:srgbClr val="19202A"/>
+                      </a:solidFill>
+                      <a:prstDash val="solid"/>
+                      <a:round/>
+                      <a:headEnd type="none" w="med" len="med"/>
+                      <a:tailEnd type="none" w="med" len="med"/>
+                    </a:lnB>
+                    <a:solidFill>
+                      <a:srgbClr val="1B2430"/>
+                    </a:solidFill>
+                  </a:tcPr>
+                </a:tc>
+              </a:tr>
+              <a:tr h="480000">
+                <a:tc>
+                  <a:txBody>
+                    <a:bodyPr/>
+                    <a:lstStyle/>
+                    <a:p>
+                      <a:pPr indent="0" marL="0">
+                        <a:lnSpc>
+                          <a:spcPts val="1960"/>
+                        </a:lnSpc>
+                        <a:buNone/>
+                      </a:pPr>
+                      <a:r>
+                        <a:rPr lang="en-US" sz="1300" dirty="0">
+                          <a:solidFill>
+                            <a:srgbClr val="1B2430"/>
+                          </a:solidFill>
+                          <a:latin typeface="Helvetica" pitchFamily="34" charset="0"/>
+                          <a:ea typeface="Helvetica" pitchFamily="34" charset="-122"/>
+                          <a:cs typeface="Helvetica" pitchFamily="34" charset="-120"/>
+                        </a:rPr>
+                        <a:t>Se puede publicar un Borrador con la fecha ya vencida</a:t>
+                      </a:r>
+                      <a:endParaRPr lang="en-US" sz="1400" dirty="0">
+                        <a:latin typeface="Helvetica" charset="0"/>
+                        <a:ea typeface="Helvetica" charset="0"/>
+                        <a:cs typeface="Helvetica" charset="0"/>
+                      </a:endParaRPr>
+                    </a:p>
+                  </a:txBody>
+                  <a:tcPr marL="114300" marR="114300" marT="76200" marB="76200" anchor="t">
+                    <a:lnL w="12700" cap="flat" cmpd="sng" algn="ctr">
+                      <a:solidFill>
+                        <a:srgbClr val="C4C3BF"/>
+                      </a:solidFill>
+                      <a:prstDash val="solid"/>
+                      <a:round/>
+                      <a:headEnd type="none" w="med" len="med"/>
+                      <a:tailEnd type="none" w="med" len="med"/>
+                    </a:lnL>
+                    <a:lnR w="12700" cap="flat" cmpd="sng" algn="ctr">
+                      <a:solidFill>
+                        <a:srgbClr val="C4C3BF"/>
+                      </a:solidFill>
+                      <a:prstDash val="solid"/>
+                      <a:round/>
+                      <a:headEnd type="none" w="med" len="med"/>
+                      <a:tailEnd type="none" w="med" len="med"/>
+                    </a:lnR>
+                    <a:lnT w="12700" cap="flat" cmpd="sng" algn="ctr">
+                      <a:solidFill>
+                        <a:srgbClr val="19202A"/>
+                      </a:solidFill>
+                      <a:prstDash val="solid"/>
+                      <a:round/>
+                      <a:headEnd type="none" w="med" len="med"/>
+                      <a:tailEnd type="none" w="med" len="med"/>
+                    </a:lnT>
+                    <a:lnB w="12700" cap="flat" cmpd="sng" algn="ctr">
+                      <a:solidFill>
+                        <a:srgbClr val="C4C3BF"/>
+                      </a:solidFill>
+                      <a:prstDash val="solid"/>
+                      <a:round/>
+                      <a:headEnd type="none" w="med" len="med"/>
+                      <a:tailEnd type="none" w="med" len="med"/>
+                    </a:lnB>
+                  </a:tcPr>
+                </a:tc>
+                <a:tc>
+                  <a:txBody>
+                    <a:bodyPr/>
+                    <a:lstStyle/>
+                    <a:p>
+                      <a:pPr indent="0" marL="0">
+                        <a:lnSpc>
+                          <a:spcPts val="1960"/>
+                        </a:lnSpc>
+                        <a:buNone/>
+                      </a:pPr>
+                      <a:r>
+                        <a:rPr lang="en-US" sz="1300" dirty="0">
+                          <a:solidFill>
+                            <a:srgbClr val="1B2430"/>
+                          </a:solidFill>
+                          <a:latin typeface="Helvetica" pitchFamily="34" charset="0"/>
+                          <a:ea typeface="Helvetica" pitchFamily="34" charset="-122"/>
+                          <a:cs typeface="Helvetica" pitchFamily="34" charset="-120"/>
+                        </a:rPr>
+                        <a:t>FEC-06</a:t>
+                      </a:r>
+                      <a:endParaRPr lang="en-US" sz="1400" dirty="0">
+                        <a:latin typeface="Helvetica" charset="0"/>
+                        <a:ea typeface="Helvetica" charset="0"/>
+                        <a:cs typeface="Helvetica" charset="0"/>
+                      </a:endParaRPr>
+                    </a:p>
+                  </a:txBody>
+                  <a:tcPr marL="114300" marR="114300" marT="76200" marB="76200" anchor="t">
+                    <a:lnL w="12700" cap="flat" cmpd="sng" algn="ctr">
+                      <a:solidFill>
+                        <a:srgbClr val="C4C3BF"/>
+                      </a:solidFill>
+                      <a:prstDash val="solid"/>
+                      <a:round/>
+                      <a:headEnd type="none" w="med" len="med"/>
+                      <a:tailEnd type="none" w="med" len="med"/>
+                    </a:lnL>
+                    <a:lnR w="12700" cap="flat" cmpd="sng" algn="ctr">
+                      <a:solidFill>
+                        <a:srgbClr val="C4C3BF"/>
+                      </a:solidFill>
+                      <a:prstDash val="solid"/>
+                      <a:round/>
+                      <a:headEnd type="none" w="med" len="med"/>
+                      <a:tailEnd type="none" w="med" len="med"/>
+                    </a:lnR>
+                    <a:lnT w="12700" cap="flat" cmpd="sng" algn="ctr">
+                      <a:solidFill>
+                        <a:srgbClr val="19202A"/>
+                      </a:solidFill>
+                      <a:prstDash val="solid"/>
+                      <a:round/>
+                      <a:headEnd type="none" w="med" len="med"/>
+                      <a:tailEnd type="none" w="med" len="med"/>
+                    </a:lnT>
+                    <a:lnB w="12700" cap="flat" cmpd="sng" algn="ctr">
+                      <a:solidFill>
+                        <a:srgbClr val="C4C3BF"/>
+                      </a:solidFill>
+                      <a:prstDash val="solid"/>
+                      <a:round/>
+                      <a:headEnd type="none" w="med" len="med"/>
+                      <a:tailEnd type="none" w="med" len="med"/>
+                    </a:lnB>
+                  </a:tcPr>
+                </a:tc>
+                <a:tc>
+                  <a:txBody>
+                    <a:bodyPr/>
+                    <a:lstStyle/>
+                    <a:p>
+                      <a:pPr indent="0" marL="0">
+                        <a:lnSpc>
+                          <a:spcPts val="1960"/>
+                        </a:lnSpc>
+                        <a:buNone/>
+                      </a:pPr>
+                      <a:r>
+                        <a:rPr lang="en-US" sz="1300" dirty="0">
+                          <a:solidFill>
+                            <a:srgbClr val="1B2430"/>
+                          </a:solidFill>
+                          <a:latin typeface="Helvetica" pitchFamily="34" charset="0"/>
+                          <a:ea typeface="Helvetica" pitchFamily="34" charset="-122"/>
+                          <a:cs typeface="Helvetica" pitchFamily="34" charset="-120"/>
+                        </a:rPr>
+                        <a:t>Alta</a:t>
+                      </a:r>
+                      <a:endParaRPr lang="en-US" sz="1400" dirty="0">
+                        <a:latin typeface="Helvetica" charset="0"/>
+                        <a:ea typeface="Helvetica" charset="0"/>
+                        <a:cs typeface="Helvetica" charset="0"/>
+                      </a:endParaRPr>
+                    </a:p>
+                  </a:txBody>
+                  <a:tcPr marL="114300" marR="114300" marT="76200" marB="76200" anchor="t">
+                    <a:lnL w="12700" cap="flat" cmpd="sng" algn="ctr">
+                      <a:solidFill>
+                        <a:srgbClr val="C4C3BF"/>
+                      </a:solidFill>
+                      <a:prstDash val="solid"/>
+                      <a:round/>
+                      <a:headEnd type="none" w="med" len="med"/>
+                      <a:tailEnd type="none" w="med" len="med"/>
+                    </a:lnL>
+                    <a:lnR w="12700" cap="flat" cmpd="sng" algn="ctr">
+                      <a:solidFill>
+                        <a:srgbClr val="C4C3BF"/>
+                      </a:solidFill>
+                      <a:prstDash val="solid"/>
+                      <a:round/>
+                      <a:headEnd type="none" w="med" len="med"/>
+                      <a:tailEnd type="none" w="med" len="med"/>
+                    </a:lnR>
+                    <a:lnT w="12700" cap="flat" cmpd="sng" algn="ctr">
+                      <a:solidFill>
+                        <a:srgbClr val="19202A"/>
+                      </a:solidFill>
+                      <a:prstDash val="solid"/>
+                      <a:round/>
+                      <a:headEnd type="none" w="med" len="med"/>
+                      <a:tailEnd type="none" w="med" len="med"/>
+                    </a:lnT>
+                    <a:lnB w="12700" cap="flat" cmpd="sng" algn="ctr">
+                      <a:solidFill>
+                        <a:srgbClr val="C4C3BF"/>
+                      </a:solidFill>
+                      <a:prstDash val="solid"/>
+                      <a:round/>
+                      <a:headEnd type="none" w="med" len="med"/>
+                      <a:tailEnd type="none" w="med" len="med"/>
+                    </a:lnB>
+                  </a:tcPr>
+                </a:tc>
+              </a:tr>
+              <a:tr h="480000">
+                <a:tc>
+                  <a:txBody>
+                    <a:bodyPr/>
+                    <a:lstStyle/>
+                    <a:p>
+                      <a:pPr indent="0" marL="0">
+                        <a:lnSpc>
+                          <a:spcPts val="1960"/>
+                        </a:lnSpc>
+                        <a:buNone/>
+                      </a:pPr>
+                      <a:r>
+                        <a:rPr lang="en-US" sz="1300" dirty="0">
+                          <a:solidFill>
+                            <a:srgbClr val="1B2430"/>
+                          </a:solidFill>
+                          <a:latin typeface="Helvetica" pitchFamily="34" charset="0"/>
+                          <a:ea typeface="Helvetica" pitchFamily="34" charset="-122"/>
+                          <a:cs typeface="Helvetica" pitchFamily="34" charset="-120"/>
+                        </a:rPr>
+                        <a:t>El historial de un Borrador se ve sin sesión</a:t>
+                      </a:r>
+                      <a:endParaRPr lang="en-US" sz="1400" dirty="0">
+                        <a:latin typeface="Helvetica" charset="0"/>
+                        <a:ea typeface="Helvetica" charset="0"/>
+                        <a:cs typeface="Helvetica" charset="0"/>
+                      </a:endParaRPr>
+                    </a:p>
+                  </a:txBody>
+                  <a:tcPr marL="114300" marR="114300" marT="76200" marB="76200" anchor="t">
+                    <a:lnL w="12700" cap="flat" cmpd="sng" algn="ctr">
+                      <a:solidFill>
+                        <a:srgbClr val="C4C3BF"/>
+                      </a:solidFill>
+                      <a:prstDash val="solid"/>
+                      <a:round/>
+                      <a:headEnd type="none" w="med" len="med"/>
+                      <a:tailEnd type="none" w="med" len="med"/>
+                    </a:lnL>
+                    <a:lnR w="12700" cap="flat" cmpd="sng" algn="ctr">
+                      <a:solidFill>
+                        <a:srgbClr val="C4C3BF"/>
+                      </a:solidFill>
+                      <a:prstDash val="solid"/>
+                      <a:round/>
+                      <a:headEnd type="none" w="med" len="med"/>
+                      <a:tailEnd type="none" w="med" len="med"/>
+                    </a:lnR>
+                    <a:lnT w="12700" cap="flat" cmpd="sng" algn="ctr">
+                      <a:solidFill>
+                        <a:srgbClr val="C4C3BF"/>
+                      </a:solidFill>
+                      <a:prstDash val="solid"/>
+                      <a:round/>
+                      <a:headEnd type="none" w="med" len="med"/>
+                      <a:tailEnd type="none" w="med" len="med"/>
+                    </a:lnT>
+                    <a:lnB w="12700" cap="flat" cmpd="sng" algn="ctr">
+                      <a:solidFill>
+                        <a:srgbClr val="C4C3BF"/>
+                      </a:solidFill>
+                      <a:prstDash val="solid"/>
+                      <a:round/>
+                      <a:headEnd type="none" w="med" len="med"/>
+                      <a:tailEnd type="none" w="med" len="med"/>
+                    </a:lnB>
+                  </a:tcPr>
+                </a:tc>
+                <a:tc>
+                  <a:txBody>
+                    <a:bodyPr/>
+                    <a:lstStyle/>
+                    <a:p>
+                      <a:pPr indent="0" marL="0">
+                        <a:lnSpc>
+                          <a:spcPts val="1960"/>
+                        </a:lnSpc>
+                        <a:buNone/>
+                      </a:pPr>
+                      <a:r>
+                        <a:rPr lang="en-US" sz="1300" dirty="0">
+                          <a:solidFill>
+                            <a:srgbClr val="1B2430"/>
+                          </a:solidFill>
+                          <a:latin typeface="Helvetica" pitchFamily="34" charset="0"/>
+                          <a:ea typeface="Helvetica" pitchFamily="34" charset="-122"/>
+                          <a:cs typeface="Helvetica" pitchFamily="34" charset="-120"/>
+                        </a:rPr>
+                        <a:t>EXP-03</a:t>
+                      </a:r>
+                      <a:endParaRPr lang="en-US" sz="1400" dirty="0">
+                        <a:latin typeface="Helvetica" charset="0"/>
+                        <a:ea typeface="Helvetica" charset="0"/>
+                        <a:cs typeface="Helvetica" charset="0"/>
+                      </a:endParaRPr>
+                    </a:p>
+                  </a:txBody>
+                  <a:tcPr marL="114300" marR="114300" marT="76200" marB="76200" anchor="t">
+                    <a:lnL w="12700" cap="flat" cmpd="sng" algn="ctr">
+                      <a:solidFill>
+                        <a:srgbClr val="C4C3BF"/>
+                      </a:solidFill>
+                      <a:prstDash val="solid"/>
+                      <a:round/>
+                      <a:headEnd type="none" w="med" len="med"/>
+                      <a:tailEnd type="none" w="med" len="med"/>
+                    </a:lnL>
+                    <a:lnR w="12700" cap="flat" cmpd="sng" algn="ctr">
+                      <a:solidFill>
+                        <a:srgbClr val="C4C3BF"/>
+                      </a:solidFill>
+                      <a:prstDash val="solid"/>
+                      <a:round/>
+                      <a:headEnd type="none" w="med" len="med"/>
+                      <a:tailEnd type="none" w="med" len="med"/>
+                    </a:lnR>
+                    <a:lnT w="12700" cap="flat" cmpd="sng" algn="ctr">
+                      <a:solidFill>
+                        <a:srgbClr val="C4C3BF"/>
+                      </a:solidFill>
+                      <a:prstDash val="solid"/>
+                      <a:round/>
+                      <a:headEnd type="none" w="med" len="med"/>
+                      <a:tailEnd type="none" w="med" len="med"/>
+                    </a:lnT>
+                    <a:lnB w="12700" cap="flat" cmpd="sng" algn="ctr">
+                      <a:solidFill>
+                        <a:srgbClr val="C4C3BF"/>
+                      </a:solidFill>
+                      <a:prstDash val="solid"/>
+                      <a:round/>
+                      <a:headEnd type="none" w="med" len="med"/>
+                      <a:tailEnd type="none" w="med" len="med"/>
+                    </a:lnB>
+                  </a:tcPr>
+                </a:tc>
+                <a:tc>
+                  <a:txBody>
+                    <a:bodyPr/>
+                    <a:lstStyle/>
+                    <a:p>
+                      <a:pPr indent="0" marL="0">
+                        <a:lnSpc>
+                          <a:spcPts val="1960"/>
+                        </a:lnSpc>
+                        <a:buNone/>
+                      </a:pPr>
+                      <a:r>
+                        <a:rPr lang="en-US" sz="1300" dirty="0">
+                          <a:solidFill>
+                            <a:srgbClr val="1B2430"/>
+                          </a:solidFill>
+                          <a:latin typeface="Helvetica" pitchFamily="34" charset="0"/>
+                          <a:ea typeface="Helvetica" pitchFamily="34" charset="-122"/>
+                          <a:cs typeface="Helvetica" pitchFamily="34" charset="-120"/>
+                        </a:rPr>
+                        <a:t>Media</a:t>
+                      </a:r>
+                      <a:endParaRPr lang="en-US" sz="1400" dirty="0">
+                        <a:latin typeface="Helvetica" charset="0"/>
+                        <a:ea typeface="Helvetica" charset="0"/>
+                        <a:cs typeface="Helvetica" charset="0"/>
+                      </a:endParaRPr>
+                    </a:p>
+                  </a:txBody>
+                  <a:tcPr marL="114300" marR="114300" marT="76200" marB="76200" anchor="t">
+                    <a:lnL w="12700" cap="flat" cmpd="sng" algn="ctr">
+                      <a:solidFill>
+                        <a:srgbClr val="C4C3BF"/>
+                      </a:solidFill>
+                      <a:prstDash val="solid"/>
+                      <a:round/>
+                      <a:headEnd type="none" w="med" len="med"/>
+                      <a:tailEnd type="none" w="med" len="med"/>
+                    </a:lnL>
+                    <a:lnR w="12700" cap="flat" cmpd="sng" algn="ctr">
+                      <a:solidFill>
+                        <a:srgbClr val="C4C3BF"/>
+                      </a:solidFill>
+                      <a:prstDash val="solid"/>
+                      <a:round/>
+                      <a:headEnd type="none" w="med" len="med"/>
+                      <a:tailEnd type="none" w="med" len="med"/>
+                    </a:lnR>
+                    <a:lnT w="12700" cap="flat" cmpd="sng" algn="ctr">
+                      <a:solidFill>
+                        <a:srgbClr val="C4C3BF"/>
+                      </a:solidFill>
+                      <a:prstDash val="solid"/>
+                      <a:round/>
+                      <a:headEnd type="none" w="med" len="med"/>
+                      <a:tailEnd type="none" w="med" len="med"/>
+                    </a:lnT>
+                    <a:lnB w="12700" cap="flat" cmpd="sng" algn="ctr">
+                      <a:solidFill>
+                        <a:srgbClr val="C4C3BF"/>
+                      </a:solidFill>
+                      <a:prstDash val="solid"/>
+                      <a:round/>
+                      <a:headEnd type="none" w="med" len="med"/>
+                      <a:tailEnd type="none" w="med" len="med"/>
+                    </a:lnB>
+                  </a:tcPr>
+                </a:tc>
+              </a:tr>
+              <a:tr h="480000">
+                <a:tc>
+                  <a:txBody>
+                    <a:bodyPr/>
+                    <a:lstStyle/>
+                    <a:p>
+                      <a:pPr indent="0" marL="0">
+                        <a:lnSpc>
+                          <a:spcPts val="1960"/>
+                        </a:lnSpc>
+                        <a:buNone/>
+                      </a:pPr>
+                      <a:r>
+                        <a:rPr lang="en-US" sz="1300" dirty="0">
+                          <a:solidFill>
+                            <a:srgbClr val="1B2430"/>
+                          </a:solidFill>
+                          <a:latin typeface="Helvetica" pitchFamily="34" charset="0"/>
+                          <a:ea typeface="Helvetica" pitchFamily="34" charset="-122"/>
+                          <a:cs typeface="Helvetica" pitchFamily="34" charset="-120"/>
+                        </a:rPr>
+                        <a:t>Un organizador lee eventos ajenos por el GET compartido</a:t>
+                      </a:r>
+                      <a:endParaRPr lang="en-US" sz="1400" dirty="0">
+                        <a:latin typeface="Helvetica" charset="0"/>
+                        <a:ea typeface="Helvetica" charset="0"/>
+                        <a:cs typeface="Helvetica" charset="0"/>
+                      </a:endParaRPr>
+                    </a:p>
+                  </a:txBody>
+                  <a:tcPr marL="114300" marR="114300" marT="76200" marB="76200" anchor="t">
+                    <a:lnL w="12700" cap="flat" cmpd="sng" algn="ctr">
+                      <a:solidFill>
+                        <a:srgbClr val="C4C3BF"/>
+                      </a:solidFill>
+                      <a:prstDash val="solid"/>
+                      <a:round/>
+                      <a:headEnd type="none" w="med" len="med"/>
+                      <a:tailEnd type="none" w="med" len="med"/>
+                    </a:lnL>
+                    <a:lnR w="12700" cap="flat" cmpd="sng" algn="ctr">
+                      <a:solidFill>
+                        <a:srgbClr val="C4C3BF"/>
+                      </a:solidFill>
+                      <a:prstDash val="solid"/>
+                      <a:round/>
+                      <a:headEnd type="none" w="med" len="med"/>
+                      <a:tailEnd type="none" w="med" len="med"/>
+                    </a:lnR>
+                    <a:lnT w="12700" cap="flat" cmpd="sng" algn="ctr">
+                      <a:solidFill>
+                        <a:srgbClr val="C4C3BF"/>
+                      </a:solidFill>
+                      <a:prstDash val="solid"/>
+                      <a:round/>
+                      <a:headEnd type="none" w="med" len="med"/>
+                      <a:tailEnd type="none" w="med" len="med"/>
+                    </a:lnT>
+                    <a:lnB w="12700" cap="flat" cmpd="sng" algn="ctr">
+                      <a:solidFill>
+                        <a:srgbClr val="C4C3BF"/>
+                      </a:solidFill>
+                      <a:prstDash val="solid"/>
+                      <a:round/>
+                      <a:headEnd type="none" w="med" len="med"/>
+                      <a:tailEnd type="none" w="med" len="med"/>
+                    </a:lnB>
+                  </a:tcPr>
+                </a:tc>
+                <a:tc>
+                  <a:txBody>
+                    <a:bodyPr/>
+                    <a:lstStyle/>
+                    <a:p>
+                      <a:pPr indent="0" marL="0">
+                        <a:lnSpc>
+                          <a:spcPts val="1960"/>
+                        </a:lnSpc>
+                        <a:buNone/>
+                      </a:pPr>
+                      <a:r>
+                        <a:rPr lang="en-US" sz="1300" dirty="0">
+                          <a:solidFill>
+                            <a:srgbClr val="1B2430"/>
+                          </a:solidFill>
+                          <a:latin typeface="Helvetica" pitchFamily="34" charset="0"/>
+                          <a:ea typeface="Helvetica" pitchFamily="34" charset="-122"/>
+                          <a:cs typeface="Helvetica" pitchFamily="34" charset="-120"/>
+                        </a:rPr>
+                        <a:t>PRO-04</a:t>
+                      </a:r>
+                      <a:endParaRPr lang="en-US" sz="1400" dirty="0">
+                        <a:latin typeface="Helvetica" charset="0"/>
+                        <a:ea typeface="Helvetica" charset="0"/>
+                        <a:cs typeface="Helvetica" charset="0"/>
+                      </a:endParaRPr>
+                    </a:p>
+                  </a:txBody>
+                  <a:tcPr marL="114300" marR="114300" marT="76200" marB="76200" anchor="t">
+                    <a:lnL w="12700" cap="flat" cmpd="sng" algn="ctr">
+                      <a:solidFill>
+                        <a:srgbClr val="C4C3BF"/>
+                      </a:solidFill>
+                      <a:prstDash val="solid"/>
+                      <a:round/>
+                      <a:headEnd type="none" w="med" len="med"/>
+                      <a:tailEnd type="none" w="med" len="med"/>
+                    </a:lnL>
+                    <a:lnR w="12700" cap="flat" cmpd="sng" algn="ctr">
+                      <a:solidFill>
+                        <a:srgbClr val="C4C3BF"/>
+                      </a:solidFill>
+                      <a:prstDash val="solid"/>
+                      <a:round/>
+                      <a:headEnd type="none" w="med" len="med"/>
+                      <a:tailEnd type="none" w="med" len="med"/>
+                    </a:lnR>
+                    <a:lnT w="12700" cap="flat" cmpd="sng" algn="ctr">
+                      <a:solidFill>
+                        <a:srgbClr val="C4C3BF"/>
+                      </a:solidFill>
+                      <a:prstDash val="solid"/>
+                      <a:round/>
+                      <a:headEnd type="none" w="med" len="med"/>
+                      <a:tailEnd type="none" w="med" len="med"/>
+                    </a:lnT>
+                    <a:lnB w="12700" cap="flat" cmpd="sng" algn="ctr">
+                      <a:solidFill>
+                        <a:srgbClr val="C4C3BF"/>
+                      </a:solidFill>
+                      <a:prstDash val="solid"/>
+                      <a:round/>
+                      <a:headEnd type="none" w="med" len="med"/>
+                      <a:tailEnd type="none" w="med" len="med"/>
+                    </a:lnB>
+                  </a:tcPr>
+                </a:tc>
+                <a:tc>
+                  <a:txBody>
+                    <a:bodyPr/>
+                    <a:lstStyle/>
+                    <a:p>
+                      <a:pPr indent="0" marL="0">
+                        <a:lnSpc>
+                          <a:spcPts val="1960"/>
+                        </a:lnSpc>
+                        <a:buNone/>
+                      </a:pPr>
+                      <a:r>
+                        <a:rPr lang="en-US" sz="1300" dirty="0">
+                          <a:solidFill>
+                            <a:srgbClr val="1B2430"/>
+                          </a:solidFill>
+                          <a:latin typeface="Helvetica" pitchFamily="34" charset="0"/>
+                          <a:ea typeface="Helvetica" pitchFamily="34" charset="-122"/>
+                          <a:cs typeface="Helvetica" pitchFamily="34" charset="-120"/>
+                        </a:rPr>
+                        <a:t>Media</a:t>
+                      </a:r>
+                      <a:endParaRPr lang="en-US" sz="1400" dirty="0">
+                        <a:latin typeface="Helvetica" charset="0"/>
+                        <a:ea typeface="Helvetica" charset="0"/>
+                        <a:cs typeface="Helvetica" charset="0"/>
+                      </a:endParaRPr>
+                    </a:p>
+                  </a:txBody>
+                  <a:tcPr marL="114300" marR="114300" marT="76200" marB="76200" anchor="t">
+                    <a:lnL w="12700" cap="flat" cmpd="sng" algn="ctr">
+                      <a:solidFill>
+                        <a:srgbClr val="C4C3BF"/>
+                      </a:solidFill>
+                      <a:prstDash val="solid"/>
+                      <a:round/>
+                      <a:headEnd type="none" w="med" len="med"/>
+                      <a:tailEnd type="none" w="med" len="med"/>
+                    </a:lnL>
+                    <a:lnR w="12700" cap="flat" cmpd="sng" algn="ctr">
+                      <a:solidFill>
+                        <a:srgbClr val="C4C3BF"/>
+                      </a:solidFill>
+                      <a:prstDash val="solid"/>
+                      <a:round/>
+                      <a:headEnd type="none" w="med" len="med"/>
+                      <a:tailEnd type="none" w="med" len="med"/>
+                    </a:lnR>
+                    <a:lnT w="12700" cap="flat" cmpd="sng" algn="ctr">
+                      <a:solidFill>
+                        <a:srgbClr val="C4C3BF"/>
+                      </a:solidFill>
+                      <a:prstDash val="solid"/>
+                      <a:round/>
+                      <a:headEnd type="none" w="med" len="med"/>
+                      <a:tailEnd type="none" w="med" len="med"/>
+                    </a:lnT>
+                    <a:lnB w="12700" cap="flat" cmpd="sng" algn="ctr">
+                      <a:solidFill>
+                        <a:srgbClr val="C4C3BF"/>
+                      </a:solidFill>
+                      <a:prstDash val="solid"/>
+                      <a:round/>
+                      <a:headEnd type="none" w="med" len="med"/>
+                      <a:tailEnd type="none" w="med" len="med"/>
+                    </a:lnB>
+                  </a:tcPr>
+                </a:tc>
+              </a:tr>
+              <a:tr h="480000">
+                <a:tc>
+                  <a:txBody>
+                    <a:bodyPr/>
+                    <a:lstStyle/>
+                    <a:p>
+                      <a:pPr indent="0" marL="0">
+                        <a:lnSpc>
+                          <a:spcPts val="1960"/>
+                        </a:lnSpc>
+                        <a:buNone/>
+                      </a:pPr>
+                      <a:r>
+                        <a:rPr lang="en-US" sz="1300" dirty="0">
+                          <a:solidFill>
+                            <a:srgbClr val="1B2430"/>
+                          </a:solidFill>
+                          <a:latin typeface="Helvetica" pitchFamily="34" charset="0"/>
+                          <a:ea typeface="Helvetica" pitchFamily="34" charset="-122"/>
+                          <a:cs typeface="Helvetica" pitchFamily="34" charset="-120"/>
+                        </a:rPr>
+                        <a:t>Check-in espera otro formato de error que el resto de la API</a:t>
+                      </a:r>
+                      <a:endParaRPr lang="en-US" sz="1400" dirty="0">
+                        <a:latin typeface="Helvetica" charset="0"/>
+                        <a:ea typeface="Helvetica" charset="0"/>
+                        <a:cs typeface="Helvetica" charset="0"/>
+                      </a:endParaRPr>
+                    </a:p>
+                  </a:txBody>
+                  <a:tcPr marL="114300" marR="114300" marT="76200" marB="76200" anchor="t">
+                    <a:lnL w="12700" cap="flat" cmpd="sng" algn="ctr">
+                      <a:solidFill>
+                        <a:srgbClr val="C4C3BF"/>
+                      </a:solidFill>
+                      <a:prstDash val="solid"/>
+                      <a:round/>
+                      <a:headEnd type="none" w="med" len="med"/>
+                      <a:tailEnd type="none" w="med" len="med"/>
+                    </a:lnL>
+                    <a:lnR w="12700" cap="flat" cmpd="sng" algn="ctr">
+                      <a:solidFill>
+                        <a:srgbClr val="C4C3BF"/>
+                      </a:solidFill>
+                      <a:prstDash val="solid"/>
+                      <a:round/>
+                      <a:headEnd type="none" w="med" len="med"/>
+                      <a:tailEnd type="none" w="med" len="med"/>
+                    </a:lnR>
+                    <a:lnT w="12700" cap="flat" cmpd="sng" algn="ctr">
+                      <a:solidFill>
+                        <a:srgbClr val="C4C3BF"/>
+                      </a:solidFill>
+                      <a:prstDash val="solid"/>
+                      <a:round/>
+                      <a:headEnd type="none" w="med" len="med"/>
+                      <a:tailEnd type="none" w="med" len="med"/>
+                    </a:lnT>
+                    <a:lnB w="12700" cap="flat" cmpd="sng" algn="ctr">
+                      <a:solidFill>
+                        <a:srgbClr val="C4C3BF"/>
+                      </a:solidFill>
+                      <a:prstDash val="solid"/>
+                      <a:round/>
+                      <a:headEnd type="none" w="med" len="med"/>
+                      <a:tailEnd type="none" w="med" len="med"/>
+                    </a:lnB>
+                  </a:tcPr>
+                </a:tc>
+                <a:tc>
+                  <a:txBody>
+                    <a:bodyPr/>
+                    <a:lstStyle/>
+                    <a:p>
+                      <a:pPr indent="0" marL="0">
+                        <a:lnSpc>
+                          <a:spcPts val="1960"/>
+                        </a:lnSpc>
+                        <a:buNone/>
+                      </a:pPr>
+                      <a:r>
+                        <a:rPr lang="en-US" sz="1300" dirty="0">
+                          <a:solidFill>
+                            <a:srgbClr val="1B2430"/>
+                          </a:solidFill>
+                          <a:latin typeface="Helvetica" pitchFamily="34" charset="0"/>
+                          <a:ea typeface="Helvetica" pitchFamily="34" charset="-122"/>
+                          <a:cs typeface="Helvetica" pitchFamily="34" charset="-120"/>
+                        </a:rPr>
+                        <a:t>CON-05</a:t>
+                      </a:r>
+                      <a:endParaRPr lang="en-US" sz="1400" dirty="0">
+                        <a:latin typeface="Helvetica" charset="0"/>
+                        <a:ea typeface="Helvetica" charset="0"/>
+                        <a:cs typeface="Helvetica" charset="0"/>
+                      </a:endParaRPr>
+                    </a:p>
+                  </a:txBody>
+                  <a:tcPr marL="114300" marR="114300" marT="76200" marB="76200" anchor="t">
+                    <a:lnL w="12700" cap="flat" cmpd="sng" algn="ctr">
+                      <a:solidFill>
+                        <a:srgbClr val="C4C3BF"/>
+                      </a:solidFill>
+                      <a:prstDash val="solid"/>
+                      <a:round/>
+                      <a:headEnd type="none" w="med" len="med"/>
+                      <a:tailEnd type="none" w="med" len="med"/>
+                    </a:lnL>
+                    <a:lnR w="12700" cap="flat" cmpd="sng" algn="ctr">
+                      <a:solidFill>
+                        <a:srgbClr val="C4C3BF"/>
+                      </a:solidFill>
+                      <a:prstDash val="solid"/>
+                      <a:round/>
+                      <a:headEnd type="none" w="med" len="med"/>
+                      <a:tailEnd type="none" w="med" len="med"/>
+                    </a:lnR>
+                    <a:lnT w="12700" cap="flat" cmpd="sng" algn="ctr">
+                      <a:solidFill>
+                        <a:srgbClr val="C4C3BF"/>
+                      </a:solidFill>
+                      <a:prstDash val="solid"/>
+                      <a:round/>
+                      <a:headEnd type="none" w="med" len="med"/>
+                      <a:tailEnd type="none" w="med" len="med"/>
+                    </a:lnT>
+                    <a:lnB w="12700" cap="flat" cmpd="sng" algn="ctr">
+                      <a:solidFill>
+                        <a:srgbClr val="C4C3BF"/>
+                      </a:solidFill>
+                      <a:prstDash val="solid"/>
+                      <a:round/>
+                      <a:headEnd type="none" w="med" len="med"/>
+                      <a:tailEnd type="none" w="med" len="med"/>
+                    </a:lnB>
+                  </a:tcPr>
+                </a:tc>
+                <a:tc>
+                  <a:txBody>
+                    <a:bodyPr/>
+                    <a:lstStyle/>
+                    <a:p>
+                      <a:pPr indent="0" marL="0">
+                        <a:lnSpc>
+                          <a:spcPts val="1960"/>
+                        </a:lnSpc>
+                        <a:buNone/>
+                      </a:pPr>
+                      <a:r>
+                        <a:rPr lang="en-US" sz="1300" dirty="0">
+                          <a:solidFill>
+                            <a:srgbClr val="1B2430"/>
+                          </a:solidFill>
+                          <a:latin typeface="Helvetica" pitchFamily="34" charset="0"/>
+                          <a:ea typeface="Helvetica" pitchFamily="34" charset="-122"/>
+                          <a:cs typeface="Helvetica" pitchFamily="34" charset="-120"/>
+                        </a:rPr>
+                        <a:t>Media</a:t>
+                      </a:r>
+                      <a:endParaRPr lang="en-US" sz="1400" dirty="0">
+                        <a:latin typeface="Helvetica" charset="0"/>
+                        <a:ea typeface="Helvetica" charset="0"/>
+                        <a:cs typeface="Helvetica" charset="0"/>
+                      </a:endParaRPr>
+                    </a:p>
+                  </a:txBody>
+                  <a:tcPr marL="114300" marR="114300" marT="76200" marB="76200" anchor="t">
+                    <a:lnL w="12700" cap="flat" cmpd="sng" algn="ctr">
+                      <a:solidFill>
+                        <a:srgbClr val="C4C3BF"/>
+                      </a:solidFill>
+                      <a:prstDash val="solid"/>
+                      <a:round/>
+                      <a:headEnd type="none" w="med" len="med"/>
+                      <a:tailEnd type="none" w="med" len="med"/>
+                    </a:lnL>
+                    <a:lnR w="12700" cap="flat" cmpd="sng" algn="ctr">
+                      <a:solidFill>
+                        <a:srgbClr val="C4C3BF"/>
+                      </a:solidFill>
+                      <a:prstDash val="solid"/>
+                      <a:round/>
+                      <a:headEnd type="none" w="med" len="med"/>
+                      <a:tailEnd type="none" w="med" len="med"/>
+                    </a:lnR>
+                    <a:lnT w="12700" cap="flat" cmpd="sng" algn="ctr">
+                      <a:solidFill>
+                        <a:srgbClr val="C4C3BF"/>
+                      </a:solidFill>
+                      <a:prstDash val="solid"/>
+                      <a:round/>
+                      <a:headEnd type="none" w="med" len="med"/>
+                      <a:tailEnd type="none" w="med" len="med"/>
+                    </a:lnT>
+                    <a:lnB w="12700" cap="flat" cmpd="sng" algn="ctr">
+                      <a:solidFill>
+                        <a:srgbClr val="C4C3BF"/>
+                      </a:solidFill>
+                      <a:prstDash val="solid"/>
+                      <a:round/>
+                      <a:headEnd type="none" w="med" len="med"/>
+                      <a:tailEnd type="none" w="med" len="med"/>
+                    </a:lnB>
+                  </a:tcPr>
+                </a:tc>
+              </a:tr>
+              <a:tr h="480000">
+                <a:tc>
+                  <a:txBody>
+                    <a:bodyPr/>
+                    <a:lstStyle/>
+                    <a:p>
+                      <a:pPr indent="0" marL="0">
+                        <a:lnSpc>
+                          <a:spcPts val="1960"/>
+                        </a:lnSpc>
+                        <a:buNone/>
+                      </a:pPr>
+                      <a:r>
+                        <a:rPr lang="en-US" sz="1300" dirty="0">
+                          <a:solidFill>
+                            <a:srgbClr val="1B2430"/>
+                          </a:solidFill>
+                          <a:latin typeface="Helvetica" pitchFamily="34" charset="0"/>
+                          <a:ea typeface="Helvetica" pitchFamily="34" charset="-122"/>
+                          <a:cs typeface="Helvetica" pitchFamily="34" charset="-120"/>
+                        </a:rPr>
+                        <a:t>Broker sin acordar: HU-07 se prueba en la tabla de salida</a:t>
+                      </a:r>
+                      <a:endParaRPr lang="en-US" sz="1400" dirty="0">
+                        <a:latin typeface="Helvetica" charset="0"/>
+                        <a:ea typeface="Helvetica" charset="0"/>
+                        <a:cs typeface="Helvetica" charset="0"/>
+                      </a:endParaRPr>
+                    </a:p>
+                  </a:txBody>
+                  <a:tcPr marL="114300" marR="114300" marT="76200" marB="76200" anchor="t">
+                    <a:lnL w="12700" cap="flat" cmpd="sng" algn="ctr">
+                      <a:solidFill>
+                        <a:srgbClr val="C4C3BF"/>
+                      </a:solidFill>
+                      <a:prstDash val="solid"/>
+                      <a:round/>
+                      <a:headEnd type="none" w="med" len="med"/>
+                      <a:tailEnd type="none" w="med" len="med"/>
+                    </a:lnL>
+                    <a:lnR w="12700" cap="flat" cmpd="sng" algn="ctr">
+                      <a:solidFill>
+                        <a:srgbClr val="C4C3BF"/>
+                      </a:solidFill>
+                      <a:prstDash val="solid"/>
+                      <a:round/>
+                      <a:headEnd type="none" w="med" len="med"/>
+                      <a:tailEnd type="none" w="med" len="med"/>
+                    </a:lnR>
+                    <a:lnT w="12700" cap="flat" cmpd="sng" algn="ctr">
+                      <a:solidFill>
+                        <a:srgbClr val="C4C3BF"/>
+                      </a:solidFill>
+                      <a:prstDash val="solid"/>
+                      <a:round/>
+                      <a:headEnd type="none" w="med" len="med"/>
+                      <a:tailEnd type="none" w="med" len="med"/>
+                    </a:lnT>
+                    <a:lnB w="12700" cap="flat" cmpd="sng" algn="ctr">
+                      <a:solidFill>
+                        <a:srgbClr val="C4C3BF"/>
+                      </a:solidFill>
+                      <a:prstDash val="solid"/>
+                      <a:round/>
+                      <a:headEnd type="none" w="med" len="med"/>
+                      <a:tailEnd type="none" w="med" len="med"/>
+                    </a:lnB>
+                  </a:tcPr>
+                </a:tc>
+                <a:tc>
+                  <a:txBody>
+                    <a:bodyPr/>
+                    <a:lstStyle/>
+                    <a:p>
+                      <a:pPr indent="0" marL="0">
+                        <a:lnSpc>
+                          <a:spcPts val="1960"/>
+                        </a:lnSpc>
+                        <a:buNone/>
+                      </a:pPr>
+                      <a:r>
+                        <a:rPr lang="en-US" sz="1300" dirty="0">
+                          <a:solidFill>
+                            <a:srgbClr val="1B2430"/>
+                          </a:solidFill>
+                          <a:latin typeface="Helvetica" pitchFamily="34" charset="0"/>
+                          <a:ea typeface="Helvetica" pitchFamily="34" charset="-122"/>
+                          <a:cs typeface="Helvetica" pitchFamily="34" charset="-120"/>
+                        </a:rPr>
+                        <a:t>NOT-01</a:t>
+                      </a:r>
+                      <a:endParaRPr lang="en-US" sz="1400" dirty="0">
+                        <a:latin typeface="Helvetica" charset="0"/>
+                        <a:ea typeface="Helvetica" charset="0"/>
+                        <a:cs typeface="Helvetica" charset="0"/>
+                      </a:endParaRPr>
+                    </a:p>
+                  </a:txBody>
+                  <a:tcPr marL="114300" marR="114300" marT="76200" marB="76200" anchor="t">
+                    <a:lnL w="12700" cap="flat" cmpd="sng" algn="ctr">
+                      <a:solidFill>
+                        <a:srgbClr val="C4C3BF"/>
+                      </a:solidFill>
+                      <a:prstDash val="solid"/>
+                      <a:round/>
+                      <a:headEnd type="none" w="med" len="med"/>
+                      <a:tailEnd type="none" w="med" len="med"/>
+                    </a:lnL>
+                    <a:lnR w="12700" cap="flat" cmpd="sng" algn="ctr">
+                      <a:solidFill>
+                        <a:srgbClr val="C4C3BF"/>
+                      </a:solidFill>
+                      <a:prstDash val="solid"/>
+                      <a:round/>
+                      <a:headEnd type="none" w="med" len="med"/>
+                      <a:tailEnd type="none" w="med" len="med"/>
+                    </a:lnR>
+                    <a:lnT w="12700" cap="flat" cmpd="sng" algn="ctr">
+                      <a:solidFill>
+                        <a:srgbClr val="C4C3BF"/>
+                      </a:solidFill>
+                      <a:prstDash val="solid"/>
+                      <a:round/>
+                      <a:headEnd type="none" w="med" len="med"/>
+                      <a:tailEnd type="none" w="med" len="med"/>
+                    </a:lnT>
+                    <a:lnB w="12700" cap="flat" cmpd="sng" algn="ctr">
+                      <a:solidFill>
+                        <a:srgbClr val="C4C3BF"/>
+                      </a:solidFill>
+                      <a:prstDash val="solid"/>
+                      <a:round/>
+                      <a:headEnd type="none" w="med" len="med"/>
+                      <a:tailEnd type="none" w="med" len="med"/>
+                    </a:lnB>
+                  </a:tcPr>
+                </a:tc>
+                <a:tc>
+                  <a:txBody>
+                    <a:bodyPr/>
+                    <a:lstStyle/>
+                    <a:p>
+                      <a:pPr indent="0" marL="0">
+                        <a:lnSpc>
+                          <a:spcPts val="1960"/>
+                        </a:lnSpc>
+                        <a:buNone/>
+                      </a:pPr>
+                      <a:r>
+                        <a:rPr lang="en-US" sz="1300" dirty="0">
+                          <a:solidFill>
+                            <a:srgbClr val="1B2430"/>
+                          </a:solidFill>
+                          <a:latin typeface="Helvetica" pitchFamily="34" charset="0"/>
+                          <a:ea typeface="Helvetica" pitchFamily="34" charset="-122"/>
+                          <a:cs typeface="Helvetica" pitchFamily="34" charset="-120"/>
+                        </a:rPr>
+                        <a:t>Alta</a:t>
+                      </a:r>
+                      <a:endParaRPr lang="en-US" sz="1400" dirty="0">
+                        <a:latin typeface="Helvetica" charset="0"/>
+                        <a:ea typeface="Helvetica" charset="0"/>
+                        <a:cs typeface="Helvetica" charset="0"/>
+                      </a:endParaRPr>
+                    </a:p>
+                  </a:txBody>
+                  <a:tcPr marL="114300" marR="114300" marT="76200" marB="76200" anchor="t">
+                    <a:lnL w="12700" cap="flat" cmpd="sng" algn="ctr">
+                      <a:solidFill>
+                        <a:srgbClr val="C4C3BF"/>
+                      </a:solidFill>
+                      <a:prstDash val="solid"/>
+                      <a:round/>
+                      <a:headEnd type="none" w="med" len="med"/>
+                      <a:tailEnd type="none" w="med" len="med"/>
+                    </a:lnL>
+                    <a:lnR w="12700" cap="flat" cmpd="sng" algn="ctr">
+                      <a:solidFill>
+                        <a:srgbClr val="C4C3BF"/>
+                      </a:solidFill>
+                      <a:prstDash val="solid"/>
+                      <a:round/>
+                      <a:headEnd type="none" w="med" len="med"/>
+                      <a:tailEnd type="none" w="med" len="med"/>
+                    </a:lnR>
+                    <a:lnT w="12700" cap="flat" cmpd="sng" algn="ctr">
+                      <a:solidFill>
+                        <a:srgbClr val="C4C3BF"/>
+                      </a:solidFill>
+                      <a:prstDash val="solid"/>
+                      <a:round/>
+                      <a:headEnd type="none" w="med" len="med"/>
+                      <a:tailEnd type="none" w="med" len="med"/>
+                    </a:lnT>
+                    <a:lnB w="12700" cap="flat" cmpd="sng" algn="ctr">
+                      <a:solidFill>
+                        <a:srgbClr val="C4C3BF"/>
+                      </a:solidFill>
+                      <a:prstDash val="solid"/>
+                      <a:round/>
+                      <a:headEnd type="none" w="med" len="med"/>
+                      <a:tailEnd type="none" w="med" len="med"/>
+                    </a:lnB>
+                  </a:tcPr>
+                </a:tc>
+              </a:tr>
+              <a:tr h="480000">
+                <a:tc>
+                  <a:txBody>
+                    <a:bodyPr/>
+                    <a:lstStyle/>
+                    <a:p>
+                      <a:pPr indent="0" marL="0">
+                        <a:lnSpc>
+                          <a:spcPts val="1960"/>
+                        </a:lnSpc>
+                        <a:buNone/>
+                      </a:pPr>
+                      <a:r>
+                        <a:rPr lang="en-US" sz="1300" dirty="0">
+                          <a:solidFill>
+                            <a:srgbClr val="1B2430"/>
+                          </a:solidFill>
+                          <a:latin typeface="Helvetica" pitchFamily="34" charset="0"/>
+                          <a:ea typeface="Helvetica" pitchFamily="34" charset="-122"/>
+                          <a:cs typeface="Helvetica" pitchFamily="34" charset="-120"/>
+                        </a:rPr>
+                        <a:t>OpenAPI: tags partidos y rutas /panel y /organizador mezcladas</a:t>
+                      </a:r>
+                      <a:endParaRPr lang="en-US" sz="1400" dirty="0">
+                        <a:latin typeface="Helvetica" charset="0"/>
+                        <a:ea typeface="Helvetica" charset="0"/>
+                        <a:cs typeface="Helvetica" charset="0"/>
+                      </a:endParaRPr>
+                    </a:p>
+                  </a:txBody>
+                  <a:tcPr marL="114300" marR="114300" marT="76200" marB="76200" anchor="t">
+                    <a:lnL w="12700" cap="flat" cmpd="sng" algn="ctr">
+                      <a:solidFill>
+                        <a:srgbClr val="C4C3BF"/>
+                      </a:solidFill>
+                      <a:prstDash val="solid"/>
+                      <a:round/>
+                      <a:headEnd type="none" w="med" len="med"/>
+                      <a:tailEnd type="none" w="med" len="med"/>
+                    </a:lnL>
+                    <a:lnR w="12700" cap="flat" cmpd="sng" algn="ctr">
+                      <a:solidFill>
+                        <a:srgbClr val="C4C3BF"/>
+                      </a:solidFill>
+                      <a:prstDash val="solid"/>
+                      <a:round/>
+                      <a:headEnd type="none" w="med" len="med"/>
+                      <a:tailEnd type="none" w="med" len="med"/>
+                    </a:lnR>
+                    <a:lnT w="12700" cap="flat" cmpd="sng" algn="ctr">
+                      <a:solidFill>
+                        <a:srgbClr val="C4C3BF"/>
+                      </a:solidFill>
+                      <a:prstDash val="solid"/>
+                      <a:round/>
+                      <a:headEnd type="none" w="med" len="med"/>
+                      <a:tailEnd type="none" w="med" len="med"/>
+                    </a:lnT>
+                    <a:lnB w="12700" cap="flat" cmpd="sng" algn="ctr">
+                      <a:solidFill>
+                        <a:srgbClr val="C4C3BF"/>
+                      </a:solidFill>
+                      <a:prstDash val="solid"/>
+                      <a:round/>
+                      <a:headEnd type="none" w="med" len="med"/>
+                      <a:tailEnd type="none" w="med" len="med"/>
+                    </a:lnB>
+                  </a:tcPr>
+                </a:tc>
+                <a:tc>
+                  <a:txBody>
+                    <a:bodyPr/>
+                    <a:lstStyle/>
+                    <a:p>
+                      <a:pPr indent="0" marL="0">
+                        <a:lnSpc>
+                          <a:spcPts val="1960"/>
+                        </a:lnSpc>
+                        <a:buNone/>
+                      </a:pPr>
+                      <a:r>
+                        <a:rPr lang="en-US" sz="1300" dirty="0">
+                          <a:solidFill>
+                            <a:srgbClr val="1B2430"/>
+                          </a:solidFill>
+                          <a:latin typeface="Helvetica" pitchFamily="34" charset="0"/>
+                          <a:ea typeface="Helvetica" pitchFamily="34" charset="-122"/>
+                          <a:cs typeface="Helvetica" pitchFamily="34" charset="-120"/>
+                        </a:rPr>
+                        <a:t>CON-01</a:t>
+                      </a:r>
+                      <a:endParaRPr lang="en-US" sz="1400" dirty="0">
+                        <a:latin typeface="Helvetica" charset="0"/>
+                        <a:ea typeface="Helvetica" charset="0"/>
+                        <a:cs typeface="Helvetica" charset="0"/>
+                      </a:endParaRPr>
+                    </a:p>
+                  </a:txBody>
+                  <a:tcPr marL="114300" marR="114300" marT="76200" marB="76200" anchor="t">
+                    <a:lnL w="12700" cap="flat" cmpd="sng" algn="ctr">
+                      <a:solidFill>
+                        <a:srgbClr val="C4C3BF"/>
+                      </a:solidFill>
+                      <a:prstDash val="solid"/>
+                      <a:round/>
+                      <a:headEnd type="none" w="med" len="med"/>
+                      <a:tailEnd type="none" w="med" len="med"/>
+                    </a:lnL>
+                    <a:lnR w="12700" cap="flat" cmpd="sng" algn="ctr">
+                      <a:solidFill>
+                        <a:srgbClr val="C4C3BF"/>
+                      </a:solidFill>
+                      <a:prstDash val="solid"/>
+                      <a:round/>
+                      <a:headEnd type="none" w="med" len="med"/>
+                      <a:tailEnd type="none" w="med" len="med"/>
+                    </a:lnR>
+                    <a:lnT w="12700" cap="flat" cmpd="sng" algn="ctr">
+                      <a:solidFill>
+                        <a:srgbClr val="C4C3BF"/>
+                      </a:solidFill>
+                      <a:prstDash val="solid"/>
+                      <a:round/>
+                      <a:headEnd type="none" w="med" len="med"/>
+                      <a:tailEnd type="none" w="med" len="med"/>
+                    </a:lnT>
+                    <a:lnB w="12700" cap="flat" cmpd="sng" algn="ctr">
+                      <a:solidFill>
+                        <a:srgbClr val="C4C3BF"/>
+                      </a:solidFill>
+                      <a:prstDash val="solid"/>
+                      <a:round/>
+                      <a:headEnd type="none" w="med" len="med"/>
+                      <a:tailEnd type="none" w="med" len="med"/>
+                    </a:lnB>
+                  </a:tcPr>
+                </a:tc>
+                <a:tc>
+                  <a:txBody>
+                    <a:bodyPr/>
+                    <a:lstStyle/>
+                    <a:p>
+                      <a:pPr indent="0" marL="0">
+                        <a:lnSpc>
+                          <a:spcPts val="1960"/>
+                        </a:lnSpc>
+                        <a:buNone/>
+                      </a:pPr>
+                      <a:r>
+                        <a:rPr lang="en-US" sz="1300" dirty="0">
+                          <a:solidFill>
+                            <a:srgbClr val="1B2430"/>
+                          </a:solidFill>
+                          <a:latin typeface="Helvetica" pitchFamily="34" charset="0"/>
+                          <a:ea typeface="Helvetica" pitchFamily="34" charset="-122"/>
+                          <a:cs typeface="Helvetica" pitchFamily="34" charset="-120"/>
+                        </a:rPr>
+                        <a:t>Baja</a:t>
+                      </a:r>
+                      <a:endParaRPr lang="en-US" sz="1400" dirty="0">
+                        <a:latin typeface="Helvetica" charset="0"/>
+                        <a:ea typeface="Helvetica" charset="0"/>
+                        <a:cs typeface="Helvetica" charset="0"/>
+                      </a:endParaRPr>
+                    </a:p>
+                  </a:txBody>
+                  <a:tcPr marL="114300" marR="114300" marT="76200" marB="76200" anchor="t">
+                    <a:lnL w="12700" cap="flat" cmpd="sng" algn="ctr">
+                      <a:solidFill>
+                        <a:srgbClr val="C4C3BF"/>
+                      </a:solidFill>
+                      <a:prstDash val="solid"/>
+                      <a:round/>
+                      <a:headEnd type="none" w="med" len="med"/>
+                      <a:tailEnd type="none" w="med" len="med"/>
+                    </a:lnL>
+                    <a:lnR w="12700" cap="flat" cmpd="sng" algn="ctr">
+                      <a:solidFill>
+                        <a:srgbClr val="C4C3BF"/>
+                      </a:solidFill>
+                      <a:prstDash val="solid"/>
+                      <a:round/>
+                      <a:headEnd type="none" w="med" len="med"/>
+                      <a:tailEnd type="none" w="med" len="med"/>
+                    </a:lnR>
+                    <a:lnT w="12700" cap="flat" cmpd="sng" algn="ctr">
+                      <a:solidFill>
+                        <a:srgbClr val="C4C3BF"/>
+                      </a:solidFill>
+                      <a:prstDash val="solid"/>
+                      <a:round/>
+                      <a:headEnd type="none" w="med" len="med"/>
+                      <a:tailEnd type="none" w="med" len="med"/>
+                    </a:lnT>
+                    <a:lnB w="12700" cap="flat" cmpd="sng" algn="ctr">
+                      <a:solidFill>
+                        <a:srgbClr val="C4C3BF"/>
+                      </a:solidFill>
+                      <a:prstDash val="solid"/>
+                      <a:round/>
+                      <a:headEnd type="none" w="med" len="med"/>
+                      <a:tailEnd type="none" w="med" len="med"/>
+                    </a:lnB>
+                  </a:tcPr>
+                </a:tc>
+              </a:tr>
+            </a:tbl>
+          </a:graphicData>
+        </a:graphic>
+      </p:graphicFrame>
+      <p:sp>
+        <p:nvSpPr>
+          <p:cNvPr id="10" name="TextBox 9"/>
+          <p:cNvSpPr txBox="1"/>
+          <p:nvPr/>
+        </p:nvSpPr>
+        <p:spPr>
+          <a:xfrm>
+            <a:off x="812800" y="4980000"/>
+            <a:ext cx="10883392" cy="1150000"/>
+          </a:xfrm>
+          <a:prstGeom prst="rect">
+            <a:avLst/>
+          </a:prstGeom>
+          <a:noFill/>
+        </p:spPr>
+        <p:txBody>
+          <a:bodyPr wrap="square">
+            <a:spAutoFit/>
+          </a:bodyPr>
+          <a:lstStyle/>
+          <a:p>
+            <a:r>
+              <a:rPr sz="1100" b="1">
+                <a:solidFill>
+                  <a:srgbClr val="5B6473"/>
+                </a:solidFill>
+              </a:rPr>
+              <a:t>Códigos de los casos</a:t>
+            </a:r>
+          </a:p>
+          <a:p>
+            <a:pPr>
+              <a:spcBef>
+                <a:spcPts val="300"/>
+              </a:spcBef>
+            </a:pPr>
+            <a:r>
+              <a:rPr sz="1100" b="1">
+                <a:solidFill>
+                  <a:srgbClr val="1B7566"/>
+                </a:solidFill>
+              </a:rPr>
+              <a:t>AUT</a:t>
+            </a:r>
+            <a:r>
+              <a:rPr sz="1100" b="0">
+                <a:solidFill>
+                  <a:srgbClr val="1C2331"/>
+                </a:solidFill>
+              </a:rPr>
+              <a:t> autenticación y rol     </a:t>
+            </a:r>
+            <a:r>
+              <a:rPr sz="1100" b="1">
+                <a:solidFill>
+                  <a:srgbClr val="1B7566"/>
+                </a:solidFill>
+              </a:rPr>
+              <a:t>PRO</a:t>
+            </a:r>
+            <a:r>
+              <a:rPr sz="1100" b="0">
+                <a:solidFill>
+                  <a:srgbClr val="1C2331"/>
+                </a:solidFill>
+              </a:rPr>
+              <a:t> propiedad del evento     </a:t>
+            </a:r>
+            <a:r>
+              <a:rPr sz="1100" b="1">
+                <a:solidFill>
+                  <a:srgbClr val="1B7566"/>
+                </a:solidFill>
+              </a:rPr>
+              <a:t>PUB</a:t>
+            </a:r>
+            <a:r>
+              <a:rPr sz="1100" b="0">
+                <a:solidFill>
+                  <a:srgbClr val="1C2331"/>
+                </a:solidFill>
+              </a:rPr>
+              <a:t> publicar     </a:t>
+            </a:r>
+            <a:r>
+              <a:rPr sz="1100" b="1">
+                <a:solidFill>
+                  <a:srgbClr val="1B7566"/>
+                </a:solidFill>
+              </a:rPr>
+              <a:t>VAL</a:t>
+            </a:r>
+            <a:r>
+              <a:rPr sz="1100" b="0">
+                <a:solidFill>
+                  <a:srgbClr val="1C2331"/>
+                </a:solidFill>
+              </a:rPr>
+              <a:t> validación al crear     </a:t>
+            </a:r>
+            <a:r>
+              <a:rPr sz="1100" b="1">
+                <a:solidFill>
+                  <a:srgbClr val="1B7566"/>
+                </a:solidFill>
+              </a:rPr>
+              <a:t>FEC</a:t>
+            </a:r>
+            <a:r>
+              <a:rPr sz="1100" b="0">
+                <a:solidFill>
+                  <a:srgbClr val="1C2331"/>
+                </a:solidFill>
+              </a:rPr>
+              <a:t> fechas y horas</a:t>
+            </a:r>
+          </a:p>
+          <a:p>
+            <a:pPr>
+              <a:spcBef>
+                <a:spcPts val="300"/>
+              </a:spcBef>
+            </a:pPr>
+            <a:r>
+              <a:rPr sz="1100" b="1">
+                <a:solidFill>
+                  <a:srgbClr val="1B7566"/>
+                </a:solidFill>
+              </a:rPr>
+              <a:t>EXP</a:t>
+            </a:r>
+            <a:r>
+              <a:rPr sz="1100" b="0">
+                <a:solidFill>
+                  <a:srgbClr val="1C2331"/>
+                </a:solidFill>
+              </a:rPr>
+              <a:t> visibilidad por estado     </a:t>
+            </a:r>
+            <a:r>
+              <a:rPr sz="1100" b="1">
+                <a:solidFill>
+                  <a:srgbClr val="1B7566"/>
+                </a:solidFill>
+              </a:rPr>
+              <a:t>CON</a:t>
+            </a:r>
+            <a:r>
+              <a:rPr sz="1100" b="0">
+                <a:solidFill>
+                  <a:srgbClr val="1C2331"/>
+                </a:solidFill>
+              </a:rPr>
+              <a:t> contratos e integración     </a:t>
+            </a:r>
+            <a:r>
+              <a:rPr sz="1100" b="1">
+                <a:solidFill>
+                  <a:srgbClr val="1B7566"/>
+                </a:solidFill>
+              </a:rPr>
+              <a:t>HIS</a:t>
+            </a:r>
+            <a:r>
+              <a:rPr sz="1100" b="0">
+                <a:solidFill>
+                  <a:srgbClr val="1C2331"/>
+                </a:solidFill>
+              </a:rPr>
+              <a:t> historial de estados     </a:t>
+            </a:r>
+            <a:r>
+              <a:rPr sz="1100" b="1">
+                <a:solidFill>
+                  <a:srgbClr val="1B7566"/>
+                </a:solidFill>
+              </a:rPr>
+              <a:t>BUS</a:t>
+            </a:r>
+            <a:r>
+              <a:rPr sz="1100" b="0">
+                <a:solidFill>
+                  <a:srgbClr val="1C2331"/>
+                </a:solidFill>
+              </a:rPr>
+              <a:t> búsqueda del Catálogo     </a:t>
+            </a:r>
+            <a:r>
+              <a:rPr sz="1100" b="1">
+                <a:solidFill>
+                  <a:srgbClr val="1B7566"/>
+                </a:solidFill>
+              </a:rPr>
+              <a:t>LIS</a:t>
+            </a:r>
+            <a:r>
+              <a:rPr sz="1100" b="0">
+                <a:solidFill>
+                  <a:srgbClr val="1C2331"/>
+                </a:solidFill>
+              </a:rPr>
+              <a:t> mis eventos</a:t>
+            </a:r>
+          </a:p>
+          <a:p>
+            <a:pPr>
+              <a:spcBef>
+                <a:spcPts val="300"/>
+              </a:spcBef>
+            </a:pPr>
+            <a:r>
+              <a:rPr sz="1100" b="1">
+                <a:solidFill>
+                  <a:srgbClr val="1B7566"/>
+                </a:solidFill>
+              </a:rPr>
+              <a:t>NOT</a:t>
+            </a:r>
+            <a:r>
+              <a:rPr sz="1100" b="0">
+                <a:solidFill>
+                  <a:srgbClr val="1C2331"/>
+                </a:solidFill>
+              </a:rPr>
+              <a:t> notificar cambios (HU-07)     </a:t>
+            </a:r>
+            <a:r>
+              <a:rPr sz="1100" b="1">
+                <a:solidFill>
+                  <a:srgbClr val="1B7566"/>
+                </a:solidFill>
+              </a:rPr>
+              <a:t>ED</a:t>
+            </a:r>
+            <a:r>
+              <a:rPr sz="1100" b="0">
+                <a:solidFill>
+                  <a:srgbClr val="1C2331"/>
+                </a:solidFill>
+              </a:rPr>
+              <a:t> editar     </a:t>
+            </a:r>
+            <a:r>
+              <a:rPr sz="1100" b="1">
+                <a:solidFill>
+                  <a:srgbClr val="1B7566"/>
+                </a:solidFill>
+              </a:rPr>
+              <a:t>DEL</a:t>
+            </a:r>
+            <a:r>
+              <a:rPr sz="1100" b="0">
+                <a:solidFill>
+                  <a:srgbClr val="1C2331"/>
+                </a:solidFill>
+              </a:rPr>
+              <a:t> eliminar     </a:t>
+            </a:r>
+            <a:r>
+              <a:rPr sz="1100" b="1">
+                <a:solidFill>
+                  <a:srgbClr val="1B7566"/>
+                </a:solidFill>
+              </a:rPr>
+              <a:t>REN</a:t>
+            </a:r>
+            <a:r>
+              <a:rPr sz="1100" b="0">
+                <a:solidFill>
+                  <a:srgbClr val="1C2331"/>
+                </a:solidFill>
+              </a:rPr>
+              <a:t> rendimiento     </a:t>
+            </a:r>
+            <a:r>
+              <a:rPr sz="1100" b="1">
+                <a:solidFill>
+                  <a:srgbClr val="1B7566"/>
+                </a:solidFill>
+              </a:rPr>
+              <a:t>E2E</a:t>
+            </a:r>
+            <a:r>
+              <a:rPr sz="1100" b="0">
+                <a:solidFill>
+                  <a:srgbClr val="1C2331"/>
+                </a:solidFill>
+              </a:rPr>
+              <a:t> flujo de punta a punta</a:t>
+            </a:r>
           </a:p>
         </p:txBody>
       </p:sp>

</xml_diff>